<commit_message>
Updated Presentation with Speaker Notes
</commit_message>
<xml_diff>
--- a/reports/04-presentation/presentation.pptx
+++ b/reports/04-presentation/presentation.pptx
@@ -1531,16 +1531,48 @@
           <a:lstStyle/>
           <a:p>
             <a:pPr indent="0" lvl="0" marL="0" rtl="0" algn="l">
-              <a:spcBef>
-                <a:spcPts val="0"/>
-              </a:spcBef>
-              <a:spcAft>
-                <a:spcPts val="0"/>
-              </a:spcAft>
+              <a:lnSpc>
+                <a:spcPct val="115000"/>
+              </a:lnSpc>
+              <a:spcBef>
+                <a:spcPts val="1200"/>
+              </a:spcBef>
+              <a:spcAft>
+                <a:spcPts val="1200"/>
+              </a:spcAft>
+              <a:buClr>
+                <a:schemeClr val="dk1"/>
+              </a:buClr>
+              <a:buSzPts val="1100"/>
+              <a:buFont typeface="Arial"/>
               <a:buNone/>
             </a:pPr>
             <a:r>
-              <a:t/>
+              <a:rPr lang="en-US" sz="1100">
+                <a:latin typeface="Arial"/>
+                <a:ea typeface="Arial"/>
+                <a:cs typeface="Arial"/>
+                <a:sym typeface="Arial"/>
+              </a:rPr>
+              <a:t>Hello everyone, our project is </a:t>
+            </a:r>
+            <a:r>
+              <a:rPr b="1" lang="en-US" sz="1100">
+                <a:latin typeface="Arial"/>
+                <a:ea typeface="Arial"/>
+                <a:cs typeface="Arial"/>
+                <a:sym typeface="Arial"/>
+              </a:rPr>
+              <a:t>Poker Player Profiling: Heuristics vs. K-Means Clustering</a:t>
+            </a:r>
+            <a:r>
+              <a:rPr lang="en-US" sz="1100">
+                <a:latin typeface="Arial"/>
+                <a:ea typeface="Arial"/>
+                <a:cs typeface="Arial"/>
+                <a:sym typeface="Arial"/>
+              </a:rPr>
+              <a:t>.</a:t>
             </a:r>
             <a:endParaRPr/>
           </a:p>
@@ -1688,12 +1720,186 @@
           <a:lstStyle/>
           <a:p>
             <a:pPr indent="0" lvl="0" marL="0" rtl="0" algn="l">
-              <a:spcBef>
-                <a:spcPts val="0"/>
-              </a:spcBef>
-              <a:spcAft>
-                <a:spcPts val="0"/>
-              </a:spcAft>
+              <a:lnSpc>
+                <a:spcPct val="115000"/>
+              </a:lnSpc>
+              <a:spcBef>
+                <a:spcPts val="1200"/>
+              </a:spcBef>
+              <a:spcAft>
+                <a:spcPts val="0"/>
+              </a:spcAft>
+              <a:buClr>
+                <a:schemeClr val="dk1"/>
+              </a:buClr>
+              <a:buSzPts val="1100"/>
+              <a:buFont typeface="Arial"/>
+              <a:buNone/>
+            </a:pPr>
+            <a:r>
+              <a:rPr lang="en-US" sz="1100">
+                <a:latin typeface="Arial"/>
+                <a:ea typeface="Arial"/>
+                <a:cs typeface="Arial"/>
+                <a:sym typeface="Arial"/>
+              </a:rPr>
+              <a:t>To wrap things up, our main takeaway is that K-Means clustering produces more meaningful player groupings than the traditional heuristic approach. </a:t>
+            </a:r>
+            <a:endParaRPr sz="1100">
+              <a:latin typeface="Arial"/>
+              <a:ea typeface="Arial"/>
+              <a:cs typeface="Arial"/>
+              <a:sym typeface="Arial"/>
+            </a:endParaRPr>
+          </a:p>
+          <a:p>
+            <a:pPr indent="0" lvl="0" marL="0" rtl="0" algn="l">
+              <a:lnSpc>
+                <a:spcPct val="115000"/>
+              </a:lnSpc>
+              <a:spcBef>
+                <a:spcPts val="1200"/>
+              </a:spcBef>
+              <a:spcAft>
+                <a:spcPts val="0"/>
+              </a:spcAft>
+              <a:buClr>
+                <a:schemeClr val="dk1"/>
+              </a:buClr>
+              <a:buSzPts val="1100"/>
+              <a:buFont typeface="Arial"/>
+              <a:buNone/>
+            </a:pPr>
+            <a:r>
+              <a:rPr lang="en-US" sz="1100">
+                <a:latin typeface="Arial"/>
+                <a:ea typeface="Arial"/>
+                <a:cs typeface="Arial"/>
+                <a:sym typeface="Arial"/>
+              </a:rPr>
+              <a:t>We also want to discuss the limitations of our approach. We only used preflop features (VPIP and PFR). Postflop behavior is left out. Also, the dataset itself is from 1995 to 2001, but poker strategy has changed dramatically since then, especially with the rise of GTO play.</a:t>
+            </a:r>
+            <a:endParaRPr sz="1100">
+              <a:latin typeface="Arial"/>
+              <a:ea typeface="Arial"/>
+              <a:cs typeface="Arial"/>
+              <a:sym typeface="Arial"/>
+            </a:endParaRPr>
+          </a:p>
+          <a:p>
+            <a:pPr indent="0" lvl="0" marL="0" rtl="0" algn="l">
+              <a:lnSpc>
+                <a:spcPct val="115000"/>
+              </a:lnSpc>
+              <a:spcBef>
+                <a:spcPts val="1200"/>
+              </a:spcBef>
+              <a:spcAft>
+                <a:spcPts val="0"/>
+              </a:spcAft>
+              <a:buClr>
+                <a:schemeClr val="dk1"/>
+              </a:buClr>
+              <a:buSzPts val="1100"/>
+              <a:buFont typeface="Arial"/>
+              <a:buNone/>
+            </a:pPr>
+            <a:r>
+              <a:rPr lang="en-US" sz="1100">
+                <a:latin typeface="Arial"/>
+                <a:ea typeface="Arial"/>
+                <a:cs typeface="Arial"/>
+                <a:sym typeface="Arial"/>
+              </a:rPr>
+              <a:t>Ultimately, it was pretty interesting to see how a simple unsupervised approach can outperform domain-specific heuristics. </a:t>
+            </a:r>
+            <a:endParaRPr sz="1100">
+              <a:latin typeface="Arial"/>
+              <a:ea typeface="Arial"/>
+              <a:cs typeface="Arial"/>
+              <a:sym typeface="Arial"/>
+            </a:endParaRPr>
+          </a:p>
+          <a:p>
+            <a:pPr indent="0" lvl="0" marL="0" rtl="0" algn="l">
+              <a:lnSpc>
+                <a:spcPct val="115000"/>
+              </a:lnSpc>
+              <a:spcBef>
+                <a:spcPts val="1200"/>
+              </a:spcBef>
+              <a:spcAft>
+                <a:spcPts val="0"/>
+              </a:spcAft>
+              <a:buClr>
+                <a:schemeClr val="dk1"/>
+              </a:buClr>
+              <a:buSzPts val="1100"/>
+              <a:buFont typeface="Arial"/>
+              <a:buNone/>
+            </a:pPr>
+            <a:r>
+              <a:rPr b="1" lang="en-US" sz="1100">
+                <a:latin typeface="Arial"/>
+                <a:ea typeface="Arial"/>
+                <a:cs typeface="Arial"/>
+                <a:sym typeface="Arial"/>
+              </a:rPr>
+              <a:t>KEEP FOR QUESTIONS DO NOT READ</a:t>
+            </a:r>
+            <a:endParaRPr b="1" sz="1100">
+              <a:latin typeface="Arial"/>
+              <a:ea typeface="Arial"/>
+              <a:cs typeface="Arial"/>
+              <a:sym typeface="Arial"/>
+            </a:endParaRPr>
+          </a:p>
+          <a:p>
+            <a:pPr indent="0" lvl="0" marL="0" rtl="0" algn="l">
+              <a:lnSpc>
+                <a:spcPct val="115000"/>
+              </a:lnSpc>
+              <a:spcBef>
+                <a:spcPts val="1200"/>
+              </a:spcBef>
+              <a:spcAft>
+                <a:spcPts val="0"/>
+              </a:spcAft>
+              <a:buClr>
+                <a:schemeClr val="dk1"/>
+              </a:buClr>
+              <a:buSzPts val="1100"/>
+              <a:buFont typeface="Arial"/>
+              <a:buNone/>
+            </a:pPr>
+            <a:r>
+              <a:rPr lang="en-US" sz="1100">
+                <a:latin typeface="Arial"/>
+                <a:ea typeface="Arial"/>
+                <a:cs typeface="Arial"/>
+                <a:sym typeface="Arial"/>
+              </a:rPr>
+              <a:t>For future work, the most natural next step would be to add postflop features. We'd also want to test on a more modern dataset, ideally something that spans before and after the poker boom, to see how player profiles shift. And finally, since K-Means assumes round, equal-sized clusters, trying methods like DBSCAN or Gaussian Mixture Models might capture the actual shape of the data better.</a:t>
+            </a:r>
+            <a:endParaRPr sz="1100">
+              <a:latin typeface="Arial"/>
+              <a:ea typeface="Arial"/>
+              <a:cs typeface="Arial"/>
+              <a:sym typeface="Arial"/>
+            </a:endParaRPr>
+          </a:p>
+          <a:p>
+            <a:pPr indent="0" lvl="0" marL="0" rtl="0" algn="l">
+              <a:lnSpc>
+                <a:spcPct val="115000"/>
+              </a:lnSpc>
+              <a:spcBef>
+                <a:spcPts val="1200"/>
+              </a:spcBef>
+              <a:spcAft>
+                <a:spcPts val="1200"/>
+              </a:spcAft>
+              <a:buSzPts val="1100"/>
               <a:buNone/>
             </a:pPr>
             <a:r>
@@ -2002,16 +2208,169 @@
           <a:lstStyle/>
           <a:p>
             <a:pPr indent="0" lvl="0" marL="0" rtl="0" algn="l">
-              <a:spcBef>
-                <a:spcPts val="0"/>
-              </a:spcBef>
-              <a:spcAft>
-                <a:spcPts val="0"/>
-              </a:spcAft>
+              <a:lnSpc>
+                <a:spcPct val="115000"/>
+              </a:lnSpc>
+              <a:spcBef>
+                <a:spcPts val="1200"/>
+              </a:spcBef>
+              <a:spcAft>
+                <a:spcPts val="0"/>
+              </a:spcAft>
+              <a:buClr>
+                <a:schemeClr val="dk1"/>
+              </a:buClr>
+              <a:buSzPts val="1100"/>
+              <a:buFont typeface="Arial"/>
               <a:buNone/>
             </a:pPr>
             <a:r>
-              <a:t/>
+              <a:rPr lang="en-US" sz="1100">
+                <a:latin typeface="Arial"/>
+                <a:ea typeface="Arial"/>
+                <a:cs typeface="Arial"/>
+                <a:sym typeface="Arial"/>
+              </a:rPr>
+              <a:t>The goal is to group poker players based on how they bet, since different players have different play styles.</a:t>
+            </a:r>
+            <a:endParaRPr sz="1100">
+              <a:latin typeface="Arial"/>
+              <a:ea typeface="Arial"/>
+              <a:cs typeface="Arial"/>
+              <a:sym typeface="Arial"/>
+            </a:endParaRPr>
+          </a:p>
+          <a:p>
+            <a:pPr indent="0" lvl="0" marL="0" rtl="0" algn="l">
+              <a:lnSpc>
+                <a:spcPct val="115000"/>
+              </a:lnSpc>
+              <a:spcBef>
+                <a:spcPts val="1200"/>
+              </a:spcBef>
+              <a:spcAft>
+                <a:spcPts val="0"/>
+              </a:spcAft>
+              <a:buClr>
+                <a:schemeClr val="dk1"/>
+              </a:buClr>
+              <a:buSzPts val="1100"/>
+              <a:buFont typeface="Arial"/>
+              <a:buNone/>
+            </a:pPr>
+            <a:r>
+              <a:rPr lang="en-US" sz="1100">
+                <a:latin typeface="Arial"/>
+                <a:ea typeface="Arial"/>
+                <a:cs typeface="Arial"/>
+                <a:sym typeface="Arial"/>
+              </a:rPr>
+              <a:t>Traditionally, players are categorized using two stats: </a:t>
+            </a:r>
+            <a:r>
+              <a:rPr b="1" lang="en-US" sz="1100">
+                <a:latin typeface="Arial"/>
+                <a:ea typeface="Arial"/>
+                <a:cs typeface="Arial"/>
+                <a:sym typeface="Arial"/>
+              </a:rPr>
+              <a:t>VPIP</a:t>
+            </a:r>
+            <a:r>
+              <a:rPr lang="en-US" sz="1100">
+                <a:latin typeface="Arial"/>
+                <a:ea typeface="Arial"/>
+                <a:cs typeface="Arial"/>
+                <a:sym typeface="Arial"/>
+              </a:rPr>
+              <a:t> and </a:t>
+            </a:r>
+            <a:r>
+              <a:rPr b="1" lang="en-US" sz="1100">
+                <a:latin typeface="Arial"/>
+                <a:ea typeface="Arial"/>
+                <a:cs typeface="Arial"/>
+                <a:sym typeface="Arial"/>
+              </a:rPr>
+              <a:t>PFR</a:t>
+            </a:r>
+            <a:r>
+              <a:rPr lang="en-US" sz="1100">
+                <a:latin typeface="Arial"/>
+                <a:ea typeface="Arial"/>
+                <a:cs typeface="Arial"/>
+                <a:sym typeface="Arial"/>
+              </a:rPr>
+              <a:t>.</a:t>
+            </a:r>
+            <a:br>
+              <a:rPr lang="en-US" sz="1100">
+                <a:latin typeface="Arial"/>
+                <a:ea typeface="Arial"/>
+                <a:cs typeface="Arial"/>
+                <a:sym typeface="Arial"/>
+              </a:rPr>
+            </a:br>
+            <a:r>
+              <a:rPr lang="en-US" sz="1100">
+                <a:latin typeface="Arial"/>
+                <a:ea typeface="Arial"/>
+                <a:cs typeface="Arial"/>
+                <a:sym typeface="Arial"/>
+              </a:rPr>
+              <a:t>VPIP is how often a player voluntarily puts money into the pot, and PFR is how often they raise before the flop.</a:t>
+            </a:r>
+            <a:endParaRPr sz="1100">
+              <a:latin typeface="Arial"/>
+              <a:ea typeface="Arial"/>
+              <a:cs typeface="Arial"/>
+              <a:sym typeface="Arial"/>
+            </a:endParaRPr>
+          </a:p>
+          <a:p>
+            <a:pPr indent="0" lvl="0" marL="0" rtl="0" algn="l">
+              <a:lnSpc>
+                <a:spcPct val="115000"/>
+              </a:lnSpc>
+              <a:spcBef>
+                <a:spcPts val="1200"/>
+              </a:spcBef>
+              <a:spcAft>
+                <a:spcPts val="1200"/>
+              </a:spcAft>
+              <a:buClr>
+                <a:schemeClr val="dk1"/>
+              </a:buClr>
+              <a:buSzPts val="1100"/>
+              <a:buFont typeface="Arial"/>
+              <a:buNone/>
+            </a:pPr>
+            <a:r>
+              <a:rPr lang="en-US" sz="1100">
+                <a:latin typeface="Arial"/>
+                <a:ea typeface="Arial"/>
+                <a:cs typeface="Arial"/>
+                <a:sym typeface="Arial"/>
+              </a:rPr>
+              <a:t>Instead of relying only on fixed cutoffs, we wanted to see if </a:t>
+            </a:r>
+            <a:r>
+              <a:rPr b="1" lang="en-US" sz="1100">
+                <a:latin typeface="Arial"/>
+                <a:ea typeface="Arial"/>
+                <a:cs typeface="Arial"/>
+                <a:sym typeface="Arial"/>
+              </a:rPr>
+              <a:t>K-Means clustering</a:t>
+            </a:r>
+            <a:r>
+              <a:rPr lang="en-US" sz="1100">
+                <a:latin typeface="Arial"/>
+                <a:ea typeface="Arial"/>
+                <a:cs typeface="Arial"/>
+                <a:sym typeface="Arial"/>
+              </a:rPr>
+              <a:t> could find better groupings directly from the data.</a:t>
             </a:r>
             <a:endParaRPr/>
           </a:p>
@@ -2159,16 +2518,152 @@
           <a:lstStyle/>
           <a:p>
             <a:pPr indent="0" lvl="0" marL="0" rtl="0" algn="l">
-              <a:spcBef>
-                <a:spcPts val="0"/>
-              </a:spcBef>
-              <a:spcAft>
-                <a:spcPts val="0"/>
-              </a:spcAft>
+              <a:lnSpc>
+                <a:spcPct val="115000"/>
+              </a:lnSpc>
+              <a:spcBef>
+                <a:spcPts val="1200"/>
+              </a:spcBef>
+              <a:spcAft>
+                <a:spcPts val="0"/>
+              </a:spcAft>
+              <a:buClr>
+                <a:schemeClr val="dk1"/>
+              </a:buClr>
+              <a:buSzPts val="1100"/>
+              <a:buFont typeface="Arial"/>
               <a:buNone/>
             </a:pPr>
             <a:r>
-              <a:t/>
+              <a:rPr lang="en-US" sz="1100">
+                <a:latin typeface="Arial"/>
+                <a:ea typeface="Arial"/>
+                <a:cs typeface="Arial"/>
+                <a:sym typeface="Arial"/>
+              </a:rPr>
+              <a:t>For related work, our first source was the </a:t>
+            </a:r>
+            <a:r>
+              <a:rPr b="1" lang="en-US" sz="1100">
+                <a:latin typeface="Arial"/>
+                <a:ea typeface="Arial"/>
+                <a:cs typeface="Arial"/>
+                <a:sym typeface="Arial"/>
+              </a:rPr>
+              <a:t>IRC Poker Dataset</a:t>
+            </a:r>
+            <a:r>
+              <a:rPr lang="en-US" sz="1100">
+                <a:latin typeface="Arial"/>
+                <a:ea typeface="Arial"/>
+                <a:cs typeface="Arial"/>
+                <a:sym typeface="Arial"/>
+              </a:rPr>
+              <a:t>, which has over 10 million holdem hands, from 1995 to 2001.</a:t>
+            </a:r>
+            <a:endParaRPr sz="1100">
+              <a:latin typeface="Arial"/>
+              <a:ea typeface="Arial"/>
+              <a:cs typeface="Arial"/>
+              <a:sym typeface="Arial"/>
+            </a:endParaRPr>
+          </a:p>
+          <a:p>
+            <a:pPr indent="0" lvl="0" marL="0" rtl="0" algn="l">
+              <a:lnSpc>
+                <a:spcPct val="115000"/>
+              </a:lnSpc>
+              <a:spcBef>
+                <a:spcPts val="1200"/>
+              </a:spcBef>
+              <a:spcAft>
+                <a:spcPts val="0"/>
+              </a:spcAft>
+              <a:buClr>
+                <a:schemeClr val="dk1"/>
+              </a:buClr>
+              <a:buSzPts val="1100"/>
+              <a:buFont typeface="Arial"/>
+              <a:buNone/>
+            </a:pPr>
+            <a:r>
+              <a:rPr lang="en-US" sz="1100">
+                <a:latin typeface="Arial"/>
+                <a:ea typeface="Arial"/>
+                <a:cs typeface="Arial"/>
+                <a:sym typeface="Arial"/>
+              </a:rPr>
+              <a:t>The second part is, the traditional poker profiling method based on </a:t>
+            </a:r>
+            <a:r>
+              <a:rPr b="1" lang="en-US" sz="1100">
+                <a:latin typeface="Arial"/>
+                <a:ea typeface="Arial"/>
+                <a:cs typeface="Arial"/>
+                <a:sym typeface="Arial"/>
+              </a:rPr>
+              <a:t>VPIP and PFR heuristics</a:t>
+            </a:r>
+            <a:r>
+              <a:rPr lang="en-US" sz="1100">
+                <a:latin typeface="Arial"/>
+                <a:ea typeface="Arial"/>
+                <a:cs typeface="Arial"/>
+                <a:sym typeface="Arial"/>
+              </a:rPr>
+              <a:t>. In poker, these stats are commonly used to label players as </a:t>
+            </a:r>
+            <a:r>
+              <a:rPr b="1" lang="en-US" sz="1100">
+                <a:latin typeface="Arial"/>
+                <a:ea typeface="Arial"/>
+                <a:cs typeface="Arial"/>
+                <a:sym typeface="Arial"/>
+              </a:rPr>
+              <a:t>TAG, LAG, Fish, or Rock</a:t>
+            </a:r>
+            <a:r>
+              <a:rPr lang="en-US" sz="1100">
+                <a:latin typeface="Arial"/>
+                <a:ea typeface="Arial"/>
+                <a:cs typeface="Arial"/>
+                <a:sym typeface="Arial"/>
+              </a:rPr>
+              <a:t>.</a:t>
+            </a:r>
+            <a:endParaRPr sz="1100">
+              <a:latin typeface="Arial"/>
+              <a:ea typeface="Arial"/>
+              <a:cs typeface="Arial"/>
+              <a:sym typeface="Arial"/>
+            </a:endParaRPr>
+          </a:p>
+          <a:p>
+            <a:pPr indent="0" lvl="0" marL="0" rtl="0" algn="l">
+              <a:lnSpc>
+                <a:spcPct val="115000"/>
+              </a:lnSpc>
+              <a:spcBef>
+                <a:spcPts val="1200"/>
+              </a:spcBef>
+              <a:spcAft>
+                <a:spcPts val="1200"/>
+              </a:spcAft>
+              <a:buClr>
+                <a:schemeClr val="dk1"/>
+              </a:buClr>
+              <a:buSzPts val="1100"/>
+              <a:buFont typeface="Arial"/>
+              <a:buNone/>
+            </a:pPr>
+            <a:r>
+              <a:rPr lang="en-US" sz="1100">
+                <a:latin typeface="Arial"/>
+                <a:ea typeface="Arial"/>
+                <a:cs typeface="Arial"/>
+                <a:sym typeface="Arial"/>
+              </a:rPr>
+              <a:t>This heuristic method became our baseline to compare with the clustering approach that groups similar players together based on their VPIP and PFR values. The goal was to determine which approach better to categorize players.</a:t>
             </a:r>
             <a:endParaRPr/>
           </a:p>
@@ -2328,6 +2823,161 @@
               <a:buNone/>
             </a:pPr>
             <a:r>
+              <a:rPr lang="en-US"/>
+              <a:t>The first step we took was to preprocess the data and extract the useful information. We used a total of around 84,000 files from 3 channels (Holdem, Holdem1, holdemii) and parsed out information like player identification and the preflop action string for each round. This action string is a concise, text-based representation of every bet, raise, call, or fold that occurred before the flop in a poker hand. </a:t>
+            </a:r>
+            <a:endParaRPr/>
+          </a:p>
+          <a:p>
+            <a:pPr indent="0" lvl="0" marL="0" rtl="0" algn="l">
+              <a:lnSpc>
+                <a:spcPct val="145000"/>
+              </a:lnSpc>
+              <a:spcBef>
+                <a:spcPts val="0"/>
+              </a:spcBef>
+              <a:spcAft>
+                <a:spcPts val="0"/>
+              </a:spcAft>
+              <a:buNone/>
+            </a:pPr>
+            <a:r>
+              <a:t/>
+            </a:r>
+            <a:endParaRPr/>
+          </a:p>
+          <a:p>
+            <a:pPr indent="0" lvl="0" marL="0" rtl="0" algn="l">
+              <a:lnSpc>
+                <a:spcPct val="145000"/>
+              </a:lnSpc>
+              <a:spcBef>
+                <a:spcPts val="0"/>
+              </a:spcBef>
+              <a:spcAft>
+                <a:spcPts val="0"/>
+              </a:spcAft>
+              <a:buNone/>
+            </a:pPr>
+            <a:r>
+              <a:rPr lang="en-US"/>
+              <a:t>Using this preflop action string the VPIP and PFR is calculated. </a:t>
+            </a:r>
+            <a:endParaRPr/>
+          </a:p>
+          <a:p>
+            <a:pPr indent="0" lvl="0" marL="0" rtl="0" algn="l">
+              <a:lnSpc>
+                <a:spcPct val="145000"/>
+              </a:lnSpc>
+              <a:spcBef>
+                <a:spcPts val="0"/>
+              </a:spcBef>
+              <a:spcAft>
+                <a:spcPts val="0"/>
+              </a:spcAft>
+              <a:buNone/>
+            </a:pPr>
+            <a:r>
+              <a:t/>
+            </a:r>
+            <a:endParaRPr/>
+          </a:p>
+          <a:p>
+            <a:pPr indent="0" lvl="0" marL="0" rtl="0" algn="l">
+              <a:lnSpc>
+                <a:spcPct val="145000"/>
+              </a:lnSpc>
+              <a:spcBef>
+                <a:spcPts val="0"/>
+              </a:spcBef>
+              <a:spcAft>
+                <a:spcPts val="0"/>
+              </a:spcAft>
+              <a:buNone/>
+            </a:pPr>
+            <a:r>
+              <a:rPr lang="en-US" sz="1100">
+                <a:latin typeface="Arial"/>
+                <a:ea typeface="Arial"/>
+                <a:cs typeface="Arial"/>
+                <a:sym typeface="Arial"/>
+              </a:rPr>
+              <a:t>We tallied these up across all hands to get a single VPIP and PFR percentage for each player.</a:t>
+            </a:r>
+            <a:endParaRPr sz="1100">
+              <a:latin typeface="Arial"/>
+              <a:ea typeface="Arial"/>
+              <a:cs typeface="Arial"/>
+              <a:sym typeface="Arial"/>
+            </a:endParaRPr>
+          </a:p>
+          <a:p>
+            <a:pPr indent="0" lvl="0" marL="0" rtl="0" algn="l">
+              <a:lnSpc>
+                <a:spcPct val="145000"/>
+              </a:lnSpc>
+              <a:spcBef>
+                <a:spcPts val="0"/>
+              </a:spcBef>
+              <a:spcAft>
+                <a:spcPts val="0"/>
+              </a:spcAft>
+              <a:buNone/>
+            </a:pPr>
+            <a:r>
+              <a:rPr lang="en-US" sz="1100">
+                <a:latin typeface="Arial"/>
+                <a:ea typeface="Arial"/>
+                <a:cs typeface="Arial"/>
+                <a:sym typeface="Arial"/>
+              </a:rPr>
+              <a:t>It is important to note that only players with 30 or more played hands were used as those who played less provide less reliable hands. </a:t>
+            </a:r>
+            <a:endParaRPr sz="1100">
+              <a:latin typeface="Arial"/>
+              <a:ea typeface="Arial"/>
+              <a:cs typeface="Arial"/>
+              <a:sym typeface="Arial"/>
+            </a:endParaRPr>
+          </a:p>
+          <a:p>
+            <a:pPr indent="0" lvl="0" marL="0" rtl="0" algn="l">
+              <a:lnSpc>
+                <a:spcPct val="145000"/>
+              </a:lnSpc>
+              <a:spcBef>
+                <a:spcPts val="0"/>
+              </a:spcBef>
+              <a:spcAft>
+                <a:spcPts val="0"/>
+              </a:spcAft>
+              <a:buNone/>
+            </a:pPr>
+            <a:r>
+              <a:t/>
+            </a:r>
+            <a:endParaRPr sz="1100">
+              <a:latin typeface="Arial"/>
+              <a:ea typeface="Arial"/>
+              <a:cs typeface="Arial"/>
+              <a:sym typeface="Arial"/>
+            </a:endParaRPr>
+          </a:p>
+          <a:p>
+            <a:pPr indent="0" lvl="0" marL="0" rtl="0" algn="l">
+              <a:lnSpc>
+                <a:spcPct val="145000"/>
+              </a:lnSpc>
+              <a:spcBef>
+                <a:spcPts val="0"/>
+              </a:spcBef>
+              <a:spcAft>
+                <a:spcPts val="0"/>
+              </a:spcAft>
+              <a:buNone/>
+            </a:pPr>
+            <a:r>
               <a:t/>
             </a:r>
             <a:endParaRPr/>
@@ -2485,6 +3135,134 @@
               <a:buNone/>
             </a:pPr>
             <a:r>
+              <a:rPr lang="en-US"/>
+              <a:t>This slide shows the two approaches we conducted. </a:t>
+            </a:r>
+            <a:endParaRPr/>
+          </a:p>
+          <a:p>
+            <a:pPr indent="0" lvl="0" marL="0" rtl="0" algn="l">
+              <a:spcBef>
+                <a:spcPts val="0"/>
+              </a:spcBef>
+              <a:spcAft>
+                <a:spcPts val="0"/>
+              </a:spcAft>
+              <a:buNone/>
+            </a:pPr>
+            <a:r>
+              <a:t/>
+            </a:r>
+            <a:endParaRPr/>
+          </a:p>
+          <a:p>
+            <a:pPr indent="0" lvl="0" marL="0" rtl="0" algn="l">
+              <a:spcBef>
+                <a:spcPts val="0"/>
+              </a:spcBef>
+              <a:spcAft>
+                <a:spcPts val="0"/>
+              </a:spcAft>
+              <a:buNone/>
+            </a:pPr>
+            <a:r>
+              <a:rPr lang="en-US"/>
+              <a:t>For the heuristic approach, for </a:t>
+            </a:r>
+            <a:r>
+              <a:rPr lang="en-US"/>
+              <a:t>example</a:t>
+            </a:r>
+            <a:r>
+              <a:rPr lang="en-US"/>
+              <a:t> if the VPIP is less </a:t>
+            </a:r>
+            <a:r>
+              <a:rPr lang="en-US"/>
+              <a:t>than</a:t>
+            </a:r>
+            <a:r>
+              <a:rPr lang="en-US"/>
+              <a:t> 25% and the PFR is &lt; 15%, the player </a:t>
+            </a:r>
+            <a:r>
+              <a:rPr lang="en-US"/>
+              <a:t>exhibits Tight and Passive behavior, thus belonging to the Rock category. Similar rigid rules are applied for the rest of the categories.</a:t>
+            </a:r>
+            <a:endParaRPr/>
+          </a:p>
+          <a:p>
+            <a:pPr indent="0" lvl="0" marL="0" rtl="0" algn="l">
+              <a:spcBef>
+                <a:spcPts val="0"/>
+              </a:spcBef>
+              <a:spcAft>
+                <a:spcPts val="0"/>
+              </a:spcAft>
+              <a:buNone/>
+            </a:pPr>
+            <a:r>
+              <a:t/>
+            </a:r>
+            <a:endParaRPr/>
+          </a:p>
+          <a:p>
+            <a:pPr indent="0" lvl="0" marL="0" rtl="0" algn="l">
+              <a:spcBef>
+                <a:spcPts val="0"/>
+              </a:spcBef>
+              <a:spcAft>
+                <a:spcPts val="0"/>
+              </a:spcAft>
+              <a:buNone/>
+            </a:pPr>
+            <a:r>
+              <a:rPr lang="en-US"/>
+              <a:t>The K-means approach splits players into K groups by minimizing within-group distance. We ran K-means with K equal to 2 to 8, to check what the data prefers. The cluster quality was measured by the silhouette score, where a higher score indicates a better cluster. In the end, the final model uses K = 4 to match the four poker archetypes. </a:t>
+            </a:r>
+            <a:endParaRPr/>
+          </a:p>
+          <a:p>
+            <a:pPr indent="0" lvl="0" marL="0" rtl="0" algn="l">
+              <a:spcBef>
+                <a:spcPts val="0"/>
+              </a:spcBef>
+              <a:spcAft>
+                <a:spcPts val="0"/>
+              </a:spcAft>
+              <a:buNone/>
+            </a:pPr>
+            <a:r>
+              <a:t/>
+            </a:r>
+            <a:endParaRPr/>
+          </a:p>
+          <a:p>
+            <a:pPr indent="0" lvl="0" marL="0" rtl="0" algn="l">
+              <a:spcBef>
+                <a:spcPts val="0"/>
+              </a:spcBef>
+              <a:spcAft>
+                <a:spcPts val="0"/>
+              </a:spcAft>
+              <a:buNone/>
+            </a:pPr>
+            <a:r>
+              <a:t/>
+            </a:r>
+            <a:endParaRPr/>
+          </a:p>
+          <a:p>
+            <a:pPr indent="0" lvl="0" marL="0" rtl="0" algn="l">
+              <a:spcBef>
+                <a:spcPts val="0"/>
+              </a:spcBef>
+              <a:spcAft>
+                <a:spcPts val="0"/>
+              </a:spcAft>
+              <a:buNone/>
+            </a:pPr>
+            <a:r>
               <a:t/>
             </a:r>
             <a:endParaRPr/>
@@ -2633,16 +3411,264 @@
           <a:lstStyle/>
           <a:p>
             <a:pPr indent="0" lvl="0" marL="0" rtl="0" algn="l">
-              <a:spcBef>
-                <a:spcPts val="0"/>
-              </a:spcBef>
-              <a:spcAft>
-                <a:spcPts val="0"/>
-              </a:spcAft>
+              <a:lnSpc>
+                <a:spcPct val="115000"/>
+              </a:lnSpc>
+              <a:spcBef>
+                <a:spcPts val="1200"/>
+              </a:spcBef>
+              <a:spcAft>
+                <a:spcPts val="0"/>
+              </a:spcAft>
+              <a:buClr>
+                <a:schemeClr val="dk1"/>
+              </a:buClr>
+              <a:buSzPts val="1100"/>
+              <a:buFont typeface="Arial"/>
               <a:buNone/>
             </a:pPr>
             <a:r>
-              <a:t/>
+              <a:rPr lang="en-US" sz="1100">
+                <a:latin typeface="Arial"/>
+                <a:ea typeface="Arial"/>
+                <a:cs typeface="Arial"/>
+                <a:sym typeface="Arial"/>
+              </a:rPr>
+              <a:t>Looking at the VPIP distribution, the average player is putting money in the pot about 51% of the time, which is pretty loose by most modern poker standards. The distribution is pretty spread out with a standard deviation of 19 points.</a:t>
+            </a:r>
+            <a:endParaRPr sz="1100">
+              <a:latin typeface="Arial"/>
+              <a:ea typeface="Arial"/>
+              <a:cs typeface="Arial"/>
+              <a:sym typeface="Arial"/>
+            </a:endParaRPr>
+          </a:p>
+          <a:p>
+            <a:pPr indent="0" lvl="0" marL="0" rtl="0" algn="l">
+              <a:lnSpc>
+                <a:spcPct val="115000"/>
+              </a:lnSpc>
+              <a:spcBef>
+                <a:spcPts val="1200"/>
+              </a:spcBef>
+              <a:spcAft>
+                <a:spcPts val="0"/>
+              </a:spcAft>
+              <a:buClr>
+                <a:schemeClr val="dk1"/>
+              </a:buClr>
+              <a:buSzPts val="1100"/>
+              <a:buFont typeface="Arial"/>
+              <a:buNone/>
+            </a:pPr>
+            <a:r>
+              <a:rPr lang="en-US" sz="1100">
+                <a:latin typeface="Arial"/>
+                <a:ea typeface="Arial"/>
+                <a:cs typeface="Arial"/>
+                <a:sym typeface="Arial"/>
+              </a:rPr>
+              <a:t>PFR is a little different, with a mean of 15% but a very right skewed distribution. Most players cluster on the low end, which means they are passive raisers in the preflop part of the game.</a:t>
+            </a:r>
+            <a:endParaRPr sz="1100">
+              <a:latin typeface="Arial"/>
+              <a:ea typeface="Arial"/>
+              <a:cs typeface="Arial"/>
+              <a:sym typeface="Arial"/>
+            </a:endParaRPr>
+          </a:p>
+          <a:p>
+            <a:pPr indent="0" lvl="0" marL="0" rtl="0" algn="l">
+              <a:lnSpc>
+                <a:spcPct val="115000"/>
+              </a:lnSpc>
+              <a:spcBef>
+                <a:spcPts val="1200"/>
+              </a:spcBef>
+              <a:spcAft>
+                <a:spcPts val="0"/>
+              </a:spcAft>
+              <a:buClr>
+                <a:schemeClr val="dk1"/>
+              </a:buClr>
+              <a:buSzPts val="1100"/>
+              <a:buFont typeface="Arial"/>
+              <a:buNone/>
+            </a:pPr>
+            <a:r>
+              <a:rPr lang="en-US" sz="1100">
+                <a:latin typeface="Arial"/>
+                <a:ea typeface="Arial"/>
+                <a:cs typeface="Arial"/>
+                <a:sym typeface="Arial"/>
+              </a:rPr>
+              <a:t>When we apply the heuristic labels, we see an imbalance between the categories:</a:t>
+            </a:r>
+            <a:endParaRPr sz="1100">
+              <a:latin typeface="Arial"/>
+              <a:ea typeface="Arial"/>
+              <a:cs typeface="Arial"/>
+              <a:sym typeface="Arial"/>
+            </a:endParaRPr>
+          </a:p>
+          <a:p>
+            <a:pPr indent="-298450" lvl="0" marL="457200" rtl="0" algn="l">
+              <a:lnSpc>
+                <a:spcPct val="115000"/>
+              </a:lnSpc>
+              <a:spcBef>
+                <a:spcPts val="1200"/>
+              </a:spcBef>
+              <a:spcAft>
+                <a:spcPts val="0"/>
+              </a:spcAft>
+              <a:buClr>
+                <a:schemeClr val="dk1"/>
+              </a:buClr>
+              <a:buSzPts val="1100"/>
+              <a:buChar char="-"/>
+            </a:pPr>
+            <a:r>
+              <a:rPr lang="en-US" sz="1100">
+                <a:latin typeface="Arial"/>
+                <a:ea typeface="Arial"/>
+                <a:cs typeface="Arial"/>
+                <a:sym typeface="Arial"/>
+              </a:rPr>
+              <a:t>10 thousand players are classified as fish</a:t>
+            </a:r>
+            <a:endParaRPr sz="1100">
+              <a:latin typeface="Arial"/>
+              <a:ea typeface="Arial"/>
+              <a:cs typeface="Arial"/>
+              <a:sym typeface="Arial"/>
+            </a:endParaRPr>
+          </a:p>
+          <a:p>
+            <a:pPr indent="-298450" lvl="0" marL="457200" rtl="0" algn="l">
+              <a:lnSpc>
+                <a:spcPct val="115000"/>
+              </a:lnSpc>
+              <a:spcBef>
+                <a:spcPts val="0"/>
+              </a:spcBef>
+              <a:spcAft>
+                <a:spcPts val="0"/>
+              </a:spcAft>
+              <a:buClr>
+                <a:schemeClr val="dk1"/>
+              </a:buClr>
+              <a:buSzPts val="1100"/>
+              <a:buChar char="-"/>
+            </a:pPr>
+            <a:r>
+              <a:rPr lang="en-US" sz="1100">
+                <a:latin typeface="Arial"/>
+                <a:ea typeface="Arial"/>
+                <a:cs typeface="Arial"/>
+                <a:sym typeface="Arial"/>
+              </a:rPr>
+              <a:t>5 thousand as lag</a:t>
+            </a:r>
+            <a:endParaRPr sz="1100">
+              <a:latin typeface="Arial"/>
+              <a:ea typeface="Arial"/>
+              <a:cs typeface="Arial"/>
+              <a:sym typeface="Arial"/>
+            </a:endParaRPr>
+          </a:p>
+          <a:p>
+            <a:pPr indent="-298450" lvl="0" marL="457200" rtl="0" algn="l">
+              <a:lnSpc>
+                <a:spcPct val="115000"/>
+              </a:lnSpc>
+              <a:spcBef>
+                <a:spcPts val="0"/>
+              </a:spcBef>
+              <a:spcAft>
+                <a:spcPts val="0"/>
+              </a:spcAft>
+              <a:buClr>
+                <a:schemeClr val="dk1"/>
+              </a:buClr>
+              <a:buSzPts val="1100"/>
+              <a:buChar char="-"/>
+            </a:pPr>
+            <a:r>
+              <a:rPr lang="en-US" sz="1100">
+                <a:latin typeface="Arial"/>
+                <a:ea typeface="Arial"/>
+                <a:cs typeface="Arial"/>
+                <a:sym typeface="Arial"/>
+              </a:rPr>
+              <a:t>1 thousand as rock</a:t>
+            </a:r>
+            <a:endParaRPr sz="1100">
+              <a:latin typeface="Arial"/>
+              <a:ea typeface="Arial"/>
+              <a:cs typeface="Arial"/>
+              <a:sym typeface="Arial"/>
+            </a:endParaRPr>
+          </a:p>
+          <a:p>
+            <a:pPr indent="-298450" lvl="0" marL="457200" rtl="0" algn="l">
+              <a:lnSpc>
+                <a:spcPct val="115000"/>
+              </a:lnSpc>
+              <a:spcBef>
+                <a:spcPts val="0"/>
+              </a:spcBef>
+              <a:spcAft>
+                <a:spcPts val="0"/>
+              </a:spcAft>
+              <a:buClr>
+                <a:schemeClr val="dk1"/>
+              </a:buClr>
+              <a:buSzPts val="1100"/>
+              <a:buChar char="-"/>
+            </a:pPr>
+            <a:r>
+              <a:rPr lang="en-US" sz="1100">
+                <a:latin typeface="Arial"/>
+                <a:ea typeface="Arial"/>
+                <a:cs typeface="Arial"/>
+                <a:sym typeface="Arial"/>
+              </a:rPr>
+              <a:t>only 32 as tag</a:t>
+            </a:r>
+            <a:endParaRPr sz="1100">
+              <a:latin typeface="Arial"/>
+              <a:ea typeface="Arial"/>
+              <a:cs typeface="Arial"/>
+              <a:sym typeface="Arial"/>
+            </a:endParaRPr>
+          </a:p>
+          <a:p>
+            <a:pPr indent="0" lvl="0" marL="0" rtl="0" algn="l">
+              <a:lnSpc>
+                <a:spcPct val="115000"/>
+              </a:lnSpc>
+              <a:spcBef>
+                <a:spcPts val="1200"/>
+              </a:spcBef>
+              <a:spcAft>
+                <a:spcPts val="1200"/>
+              </a:spcAft>
+              <a:buClr>
+                <a:schemeClr val="dk1"/>
+              </a:buClr>
+              <a:buSzPts val="1100"/>
+              <a:buFont typeface="Arial"/>
+              <a:buNone/>
+            </a:pPr>
+            <a:r>
+              <a:rPr lang="en-US" sz="1100">
+                <a:latin typeface="Arial"/>
+                <a:ea typeface="Arial"/>
+                <a:cs typeface="Arial"/>
+                <a:sym typeface="Arial"/>
+              </a:rPr>
+              <a:t>We concluded that the small number of TAG players likely reflects both the era's player tendencies and also the limitations of applying modern cutoffs designed for GTO play to a 1990s dataset. </a:t>
             </a:r>
             <a:endParaRPr/>
           </a:p>
@@ -2790,16 +3816,121 @@
           <a:lstStyle/>
           <a:p>
             <a:pPr indent="0" lvl="0" marL="0" rtl="0" algn="l">
-              <a:spcBef>
-                <a:spcPts val="0"/>
-              </a:spcBef>
-              <a:spcAft>
-                <a:spcPts val="0"/>
-              </a:spcAft>
+              <a:lnSpc>
+                <a:spcPct val="115000"/>
+              </a:lnSpc>
+              <a:spcBef>
+                <a:spcPts val="1200"/>
+              </a:spcBef>
+              <a:spcAft>
+                <a:spcPts val="0"/>
+              </a:spcAft>
+              <a:buClr>
+                <a:schemeClr val="dk1"/>
+              </a:buClr>
+              <a:buSzPts val="1100"/>
+              <a:buFont typeface="Arial"/>
               <a:buNone/>
             </a:pPr>
             <a:r>
-              <a:t/>
+              <a:rPr lang="en-US"/>
+              <a:t>To choose the K value,</a:t>
+            </a:r>
+            <a:r>
+              <a:rPr lang="en-US"/>
+              <a:t> we tested values from K equals 2 through 8 and compared both inertia and silhouette scores.</a:t>
+            </a:r>
+            <a:endParaRPr/>
+          </a:p>
+          <a:p>
+            <a:pPr indent="0" lvl="0" marL="0" rtl="0" algn="l">
+              <a:lnSpc>
+                <a:spcPct val="115000"/>
+              </a:lnSpc>
+              <a:spcBef>
+                <a:spcPts val="1200"/>
+              </a:spcBef>
+              <a:spcAft>
+                <a:spcPts val="0"/>
+              </a:spcAft>
+              <a:buClr>
+                <a:schemeClr val="dk1"/>
+              </a:buClr>
+              <a:buSzPts val="1100"/>
+              <a:buFont typeface="Arial"/>
+              <a:buNone/>
+            </a:pPr>
+            <a:r>
+              <a:rPr lang="en-US"/>
+              <a:t>Inertia measures how compact the clusters are internally, so lower values are better. Silhouette score measures how well-separated the clusters are, with values closer to 1 indicating stronger clustering quality.</a:t>
+            </a:r>
+            <a:endParaRPr/>
+          </a:p>
+          <a:p>
+            <a:pPr indent="0" lvl="0" marL="0" rtl="0" algn="l">
+              <a:lnSpc>
+                <a:spcPct val="115000"/>
+              </a:lnSpc>
+              <a:spcBef>
+                <a:spcPts val="1200"/>
+              </a:spcBef>
+              <a:spcAft>
+                <a:spcPts val="0"/>
+              </a:spcAft>
+              <a:buClr>
+                <a:schemeClr val="dk1"/>
+              </a:buClr>
+              <a:buSzPts val="1100"/>
+              <a:buFont typeface="Arial"/>
+              <a:buNone/>
+            </a:pPr>
+            <a:r>
+              <a:rPr lang="en-US"/>
+              <a:t>As shown in the table, the highest silhouette score occurs at K equals 2, with a score of about 0.49. This suggests that the strongest natural split in the data is binary — likely separating tighter players from looser players.</a:t>
+            </a:r>
+            <a:endParaRPr/>
+          </a:p>
+          <a:p>
+            <a:pPr indent="0" lvl="0" marL="0" rtl="0" algn="l">
+              <a:lnSpc>
+                <a:spcPct val="115000"/>
+              </a:lnSpc>
+              <a:spcBef>
+                <a:spcPts val="1200"/>
+              </a:spcBef>
+              <a:spcAft>
+                <a:spcPts val="0"/>
+              </a:spcAft>
+              <a:buClr>
+                <a:schemeClr val="dk1"/>
+              </a:buClr>
+              <a:buSzPts val="1100"/>
+              <a:buFont typeface="Arial"/>
+              <a:buNone/>
+            </a:pPr>
+            <a:r>
+              <a:rPr lang="en-US"/>
+              <a:t>However, we ultimately selected K equals 4 for the final model. Even though the silhouette score is slightly lower at about 0.44, using four clusters aligns with the four traditional poker archetypes.</a:t>
+            </a:r>
+            <a:endParaRPr/>
+          </a:p>
+          <a:p>
+            <a:pPr indent="0" lvl="0" marL="0" rtl="0" algn="l">
+              <a:lnSpc>
+                <a:spcPct val="115000"/>
+              </a:lnSpc>
+              <a:spcBef>
+                <a:spcPts val="1200"/>
+              </a:spcBef>
+              <a:spcAft>
+                <a:spcPts val="1200"/>
+              </a:spcAft>
+              <a:buSzPts val="1100"/>
+              <a:buNone/>
+            </a:pPr>
+            <a:r>
+              <a:rPr lang="en-US"/>
+              <a:t>This gave us a balance between clustering quality and interpretability, while also allowing a direct comparison with the heuristic profiling system</a:t>
             </a:r>
             <a:endParaRPr/>
           </a:p>
@@ -2947,16 +4078,149 @@
           <a:lstStyle/>
           <a:p>
             <a:pPr indent="0" lvl="0" marL="0" rtl="0" algn="l">
-              <a:spcBef>
-                <a:spcPts val="0"/>
-              </a:spcBef>
-              <a:spcAft>
-                <a:spcPts val="0"/>
-              </a:spcAft>
+              <a:lnSpc>
+                <a:spcPct val="115000"/>
+              </a:lnSpc>
+              <a:spcBef>
+                <a:spcPts val="1200"/>
+              </a:spcBef>
+              <a:spcAft>
+                <a:spcPts val="0"/>
+              </a:spcAft>
+              <a:buClr>
+                <a:schemeClr val="dk1"/>
+              </a:buClr>
+              <a:buSzPts val="1100"/>
+              <a:buFont typeface="Arial"/>
               <a:buNone/>
             </a:pPr>
             <a:r>
-              <a:t/>
+              <a:rPr lang="en-US"/>
+              <a:t>Here we show the final K-means clustering results using K equals 4, where each color is a different cluster in the graph.</a:t>
+            </a:r>
+            <a:endParaRPr/>
+          </a:p>
+          <a:p>
+            <a:pPr indent="0" lvl="0" marL="0" rtl="0" algn="l">
+              <a:lnSpc>
+                <a:spcPct val="115000"/>
+              </a:lnSpc>
+              <a:spcBef>
+                <a:spcPts val="1200"/>
+              </a:spcBef>
+              <a:spcAft>
+                <a:spcPts val="0"/>
+              </a:spcAft>
+              <a:buClr>
+                <a:schemeClr val="dk1"/>
+              </a:buClr>
+              <a:buSzPts val="1100"/>
+              <a:buFont typeface="Arial"/>
+              <a:buNone/>
+            </a:pPr>
+            <a:r>
+              <a:rPr lang="en-US"/>
+              <a:t>Cluster 0 is the largest group, containing about 8,500 players. We interpret this cluster as tight-passive players.</a:t>
+            </a:r>
+            <a:endParaRPr/>
+          </a:p>
+          <a:p>
+            <a:pPr indent="0" lvl="0" marL="0" rtl="0" algn="l">
+              <a:lnSpc>
+                <a:spcPct val="115000"/>
+              </a:lnSpc>
+              <a:spcBef>
+                <a:spcPts val="1200"/>
+              </a:spcBef>
+              <a:spcAft>
+                <a:spcPts val="0"/>
+              </a:spcAft>
+              <a:buClr>
+                <a:schemeClr val="dk1"/>
+              </a:buClr>
+              <a:buSzPts val="1100"/>
+              <a:buFont typeface="Arial"/>
+              <a:buNone/>
+            </a:pPr>
+            <a:r>
+              <a:rPr lang="en-US"/>
+              <a:t>Cluster 2 contains loose-passive players, who enter hands but don’t raise preflop, creating a very large gap between VPIP and PFR.</a:t>
+            </a:r>
+            <a:endParaRPr/>
+          </a:p>
+          <a:p>
+            <a:pPr indent="0" lvl="0" marL="0" rtl="0" algn="l">
+              <a:lnSpc>
+                <a:spcPct val="115000"/>
+              </a:lnSpc>
+              <a:spcBef>
+                <a:spcPts val="1200"/>
+              </a:spcBef>
+              <a:spcAft>
+                <a:spcPts val="0"/>
+              </a:spcAft>
+              <a:buClr>
+                <a:schemeClr val="dk1"/>
+              </a:buClr>
+              <a:buSzPts val="1100"/>
+              <a:buFont typeface="Arial"/>
+              <a:buNone/>
+            </a:pPr>
+            <a:r>
+              <a:rPr lang="en-US"/>
+              <a:t>Cluster 3 represents moderately aggressive loose players, with high VPIP and higher PFR values.</a:t>
+            </a:r>
+            <a:endParaRPr/>
+          </a:p>
+          <a:p>
+            <a:pPr indent="0" lvl="0" marL="0" rtl="0" algn="l">
+              <a:lnSpc>
+                <a:spcPct val="115000"/>
+              </a:lnSpc>
+              <a:spcBef>
+                <a:spcPts val="1200"/>
+              </a:spcBef>
+              <a:spcAft>
+                <a:spcPts val="0"/>
+              </a:spcAft>
+              <a:buClr>
+                <a:schemeClr val="dk1"/>
+              </a:buClr>
+              <a:buSzPts val="1100"/>
+              <a:buFont typeface="Arial"/>
+              <a:buNone/>
+            </a:pPr>
+            <a:r>
+              <a:rPr lang="en-US"/>
+              <a:t>Finally, Cluster 1 is the smallest but most extreme cluster. These players enter and raise in almost every hand. We labeled this cluster hyper-aggressive.</a:t>
+            </a:r>
+            <a:endParaRPr/>
+          </a:p>
+          <a:p>
+            <a:pPr indent="0" lvl="0" marL="0" rtl="0" algn="l">
+              <a:lnSpc>
+                <a:spcPct val="115000"/>
+              </a:lnSpc>
+              <a:spcBef>
+                <a:spcPts val="1200"/>
+              </a:spcBef>
+              <a:spcAft>
+                <a:spcPts val="1200"/>
+              </a:spcAft>
+              <a:buClr>
+                <a:schemeClr val="dk1"/>
+              </a:buClr>
+              <a:buSzPts val="1100"/>
+              <a:buFont typeface="Arial"/>
+              <a:buNone/>
+            </a:pPr>
+            <a:r>
+              <a:rPr lang="en-US"/>
+              <a:t>The table on the right compares these clusters against the heuristic labels. One important result is that the heuristic LAG category gets split across multiple K-means clusters. This suggests that the heuristic system groups together players who actually behave quite differently</a:t>
+            </a:r>
+            <a:r>
+              <a:rPr lang="en-US"/>
+              <a:t>.</a:t>
             </a:r>
             <a:endParaRPr/>
           </a:p>
@@ -3104,16 +4368,166 @@
           <a:lstStyle/>
           <a:p>
             <a:pPr indent="0" lvl="0" marL="0" rtl="0" algn="l">
-              <a:spcBef>
-                <a:spcPts val="0"/>
-              </a:spcBef>
-              <a:spcAft>
-                <a:spcPts val="0"/>
-              </a:spcAft>
+              <a:lnSpc>
+                <a:spcPct val="115000"/>
+              </a:lnSpc>
+              <a:spcBef>
+                <a:spcPts val="1200"/>
+              </a:spcBef>
+              <a:spcAft>
+                <a:spcPts val="0"/>
+              </a:spcAft>
+              <a:buClr>
+                <a:schemeClr val="dk1"/>
+              </a:buClr>
+              <a:buSzPts val="1100"/>
+              <a:buFont typeface="Arial"/>
               <a:buNone/>
             </a:pPr>
             <a:r>
-              <a:t/>
+              <a:rPr lang="en-US" sz="1100">
+                <a:latin typeface="Arial"/>
+                <a:ea typeface="Arial"/>
+                <a:cs typeface="Arial"/>
+                <a:sym typeface="Arial"/>
+              </a:rPr>
+              <a:t>So, how do these two approaches actually compare?</a:t>
+            </a:r>
+            <a:endParaRPr sz="1100">
+              <a:latin typeface="Arial"/>
+              <a:ea typeface="Arial"/>
+              <a:cs typeface="Arial"/>
+              <a:sym typeface="Arial"/>
+            </a:endParaRPr>
+          </a:p>
+          <a:p>
+            <a:pPr indent="0" lvl="0" marL="0" rtl="0" algn="l">
+              <a:lnSpc>
+                <a:spcPct val="115000"/>
+              </a:lnSpc>
+              <a:spcBef>
+                <a:spcPts val="1200"/>
+              </a:spcBef>
+              <a:spcAft>
+                <a:spcPts val="0"/>
+              </a:spcAft>
+              <a:buClr>
+                <a:schemeClr val="dk1"/>
+              </a:buClr>
+              <a:buSzPts val="1100"/>
+              <a:buFont typeface="Arial"/>
+              <a:buNone/>
+            </a:pPr>
+            <a:r>
+              <a:rPr lang="en-US" sz="1100">
+                <a:latin typeface="Arial"/>
+                <a:ea typeface="Arial"/>
+                <a:cs typeface="Arial"/>
+                <a:sym typeface="Arial"/>
+              </a:rPr>
+              <a:t>The fixed cutoffs are drawing boundaries that don't align well with where the data naturally separates.</a:t>
+            </a:r>
+            <a:endParaRPr sz="1100">
+              <a:latin typeface="Arial"/>
+              <a:ea typeface="Arial"/>
+              <a:cs typeface="Arial"/>
+              <a:sym typeface="Arial"/>
+            </a:endParaRPr>
+          </a:p>
+          <a:p>
+            <a:pPr indent="0" lvl="0" marL="0" rtl="0" algn="l">
+              <a:lnSpc>
+                <a:spcPct val="115000"/>
+              </a:lnSpc>
+              <a:spcBef>
+                <a:spcPts val="1200"/>
+              </a:spcBef>
+              <a:spcAft>
+                <a:spcPts val="0"/>
+              </a:spcAft>
+              <a:buClr>
+                <a:schemeClr val="dk1"/>
+              </a:buClr>
+              <a:buSzPts val="1100"/>
+              <a:buFont typeface="Arial"/>
+              <a:buNone/>
+            </a:pPr>
+            <a:r>
+              <a:rPr lang="en-US" sz="1100">
+                <a:latin typeface="Arial"/>
+                <a:ea typeface="Arial"/>
+                <a:cs typeface="Arial"/>
+                <a:sym typeface="Arial"/>
+              </a:rPr>
+              <a:t>Looking at the silhouette plot on the left, you can see that clusters 2 and 3 are particularly tight and well-separated, while cluster 0 has more variance, which makes sense given it's the largest group.</a:t>
+            </a:r>
+            <a:endParaRPr sz="1100">
+              <a:latin typeface="Arial"/>
+              <a:ea typeface="Arial"/>
+              <a:cs typeface="Arial"/>
+              <a:sym typeface="Arial"/>
+            </a:endParaRPr>
+          </a:p>
+          <a:p>
+            <a:pPr indent="0" lvl="0" marL="0" rtl="0" algn="l">
+              <a:lnSpc>
+                <a:spcPct val="115000"/>
+              </a:lnSpc>
+              <a:spcBef>
+                <a:spcPts val="1200"/>
+              </a:spcBef>
+              <a:spcAft>
+                <a:spcPts val="0"/>
+              </a:spcAft>
+              <a:buClr>
+                <a:schemeClr val="dk1"/>
+              </a:buClr>
+              <a:buSzPts val="1100"/>
+              <a:buFont typeface="Arial"/>
+              <a:buNone/>
+            </a:pPr>
+            <a:r>
+              <a:rPr b="1" lang="en-US" sz="1100">
+                <a:latin typeface="Arial"/>
+                <a:ea typeface="Arial"/>
+                <a:cs typeface="Arial"/>
+                <a:sym typeface="Arial"/>
+              </a:rPr>
+              <a:t>KEEP FOR QUESTIONS DO NOT READ</a:t>
+            </a:r>
+            <a:endParaRPr sz="1100">
+              <a:latin typeface="Arial"/>
+              <a:ea typeface="Arial"/>
+              <a:cs typeface="Arial"/>
+              <a:sym typeface="Arial"/>
+            </a:endParaRPr>
+          </a:p>
+          <a:p>
+            <a:pPr indent="0" lvl="0" marL="0" rtl="0" algn="l">
+              <a:lnSpc>
+                <a:spcPct val="115000"/>
+              </a:lnSpc>
+              <a:spcBef>
+                <a:spcPts val="1200"/>
+              </a:spcBef>
+              <a:spcAft>
+                <a:spcPts val="1200"/>
+              </a:spcAft>
+              <a:buClr>
+                <a:schemeClr val="dk1"/>
+              </a:buClr>
+              <a:buSzPts val="1100"/>
+              <a:buFont typeface="Arial"/>
+              <a:buNone/>
+            </a:pPr>
+            <a:r>
+              <a:rPr lang="en-US" sz="1100">
+                <a:latin typeface="Arial"/>
+                <a:ea typeface="Arial"/>
+                <a:cs typeface="Arial"/>
+                <a:sym typeface="Arial"/>
+              </a:rPr>
+              <a:t>We also validated this on a smaller sampled subset of 344 players, and the same differences between the two methods showed up, with K-Means at 0.4595 versus the heuristic at 0.0990.</a:t>
             </a:r>
             <a:endParaRPr/>
           </a:p>
@@ -23038,7 +24452,33 @@
                 <a:cs typeface="Georgia"/>
                 <a:sym typeface="Georgia"/>
               </a:rPr>
-              <a:t>Same cutoff applies to everyone</a:t>
+              <a:t>Same cutoffs  applies to everyone</a:t>
+            </a:r>
+            <a:endParaRPr sz="2100">
+              <a:solidFill>
+                <a:srgbClr val="111111"/>
+              </a:solidFill>
+              <a:latin typeface="Georgia"/>
+              <a:ea typeface="Georgia"/>
+              <a:cs typeface="Georgia"/>
+              <a:sym typeface="Georgia"/>
+            </a:endParaRPr>
+          </a:p>
+          <a:p>
+            <a:pPr indent="0" lvl="0" marL="0" marR="0" rtl="0" algn="l">
+              <a:lnSpc>
+                <a:spcPct val="145000"/>
+              </a:lnSpc>
+              <a:spcBef>
+                <a:spcPts val="0"/>
+              </a:spcBef>
+              <a:spcAft>
+                <a:spcPts val="0"/>
+              </a:spcAft>
+              <a:buNone/>
+            </a:pPr>
+            <a:r>
+              <a:t/>
             </a:r>
             <a:endParaRPr sz="2100">
               <a:solidFill>
@@ -23891,7 +25331,7 @@
             <a:tbl>
               <a:tblPr>
                 <a:noFill/>
-                <a:tableStyleId>{7C1ECD97-6C2D-4FC2-9158-60245B24DD59}</a:tableStyleId>
+                <a:tableStyleId>{855232AF-9C6D-4EA2-89A8-027460FECF40}</a:tableStyleId>
               </a:tblPr>
               <a:tblGrid>
                 <a:gridCol w="1842825"/>
@@ -36817,7 +38257,7 @@
         <p:spPr>
           <a:xfrm>
             <a:off x="9528600" y="5314700"/>
-            <a:ext cx="7528500" cy="2973000"/>
+            <a:ext cx="7528500" cy="3845100"/>
           </a:xfrm>
           <a:prstGeom prst="rect">
             <a:avLst/>
@@ -37169,6 +38609,285 @@
 </file>
 
 <file path=ppt/theme/theme1.xml><?xml version="1.0" encoding="utf-8"?>
+<a:theme xmlns:a="http://schemas.openxmlformats.org/drawingml/2006/main" xmlns:r="http://schemas.openxmlformats.org/officeDocument/2006/relationships" name="Momentum">
+  <a:themeElements>
+    <a:clrScheme name="Momentum">
+      <a:dk1>
+        <a:srgbClr val="C0791B"/>
+      </a:dk1>
+      <a:lt1>
+        <a:srgbClr val="FFFFFF"/>
+      </a:lt1>
+      <a:dk2>
+        <a:srgbClr val="424242"/>
+      </a:dk2>
+      <a:lt2>
+        <a:srgbClr val="8DD8D3"/>
+      </a:lt2>
+      <a:accent1>
+        <a:srgbClr val="0B6374"/>
+      </a:accent1>
+      <a:accent2>
+        <a:srgbClr val="FD5B58"/>
+      </a:accent2>
+      <a:accent3>
+        <a:srgbClr val="599191"/>
+      </a:accent3>
+      <a:accent4>
+        <a:srgbClr val="D7E6A3"/>
+      </a:accent4>
+      <a:accent5>
+        <a:srgbClr val="27278B"/>
+      </a:accent5>
+      <a:accent6>
+        <a:srgbClr val="D558AB"/>
+      </a:accent6>
+      <a:hlink>
+        <a:srgbClr val="27278B"/>
+      </a:hlink>
+      <a:folHlink>
+        <a:srgbClr val="27278B"/>
+      </a:folHlink>
+    </a:clrScheme>
+    <a:fontScheme name="Office">
+      <a:majorFont>
+        <a:latin typeface="Arial"/>
+        <a:ea typeface=""/>
+        <a:cs typeface=""/>
+        <a:font script="Jpan" typeface="ＭＳ Ｐゴシック"/>
+        <a:font script="Hang" typeface="맑은 고딕"/>
+        <a:font script="Hans" typeface="宋体"/>
+        <a:font script="Hant" typeface="新細明體"/>
+        <a:font script="Arab" typeface="Times New Roman"/>
+        <a:font script="Hebr" typeface="Times New Roman"/>
+        <a:font script="Thai" typeface="Angsana New"/>
+        <a:font script="Ethi" typeface="Nyala"/>
+        <a:font script="Beng" typeface="Vrinda"/>
+        <a:font script="Gujr" typeface="Shruti"/>
+        <a:font script="Khmr" typeface="MoolBoran"/>
+        <a:font script="Knda" typeface="Tunga"/>
+        <a:font script="Guru" typeface="Raavi"/>
+        <a:font script="Cans" typeface="Euphemia"/>
+        <a:font script="Cher" typeface="Plantagenet Cherokee"/>
+        <a:font script="Yiii" typeface="Microsoft Yi Baiti"/>
+        <a:font script="Tibt" typeface="Microsoft Himalaya"/>
+        <a:font script="Thaa" typeface="MV Boli"/>
+        <a:font script="Deva" typeface="Mangal"/>
+        <a:font script="Telu" typeface="Gautami"/>
+        <a:font script="Taml" typeface="Latha"/>
+        <a:font script="Syrc" typeface="Estrangelo Edessa"/>
+        <a:font script="Orya" typeface="Kalinga"/>
+        <a:font script="Mlym" typeface="Kartika"/>
+        <a:font script="Laoo" typeface="DokChampa"/>
+        <a:font script="Sinh" typeface="Iskoola Pota"/>
+        <a:font script="Mong" typeface="Mongolian Baiti"/>
+        <a:font script="Viet" typeface="Times New Roman"/>
+        <a:font script="Uigh" typeface="Microsoft Uighur"/>
+        <a:font script="Geor" typeface="Sylfaen"/>
+      </a:majorFont>
+      <a:minorFont>
+        <a:latin typeface="Arial"/>
+        <a:ea typeface=""/>
+        <a:cs typeface=""/>
+        <a:font script="Jpan" typeface="ＭＳ Ｐゴシック"/>
+        <a:font script="Hang" typeface="맑은 고딕"/>
+        <a:font script="Hans" typeface="宋体"/>
+        <a:font script="Hant" typeface="新細明體"/>
+        <a:font script="Arab" typeface="Arial"/>
+        <a:font script="Hebr" typeface="Arial"/>
+        <a:font script="Thai" typeface="Cordia New"/>
+        <a:font script="Ethi" typeface="Nyala"/>
+        <a:font script="Beng" typeface="Vrinda"/>
+        <a:font script="Gujr" typeface="Shruti"/>
+        <a:font script="Khmr" typeface="DaunPenh"/>
+        <a:font script="Knda" typeface="Tunga"/>
+        <a:font script="Guru" typeface="Raavi"/>
+        <a:font script="Cans" typeface="Euphemia"/>
+        <a:font script="Cher" typeface="Plantagenet Cherokee"/>
+        <a:font script="Yiii" typeface="Microsoft Yi Baiti"/>
+        <a:font script="Tibt" typeface="Microsoft Himalaya"/>
+        <a:font script="Thaa" typeface="MV Boli"/>
+        <a:font script="Deva" typeface="Mangal"/>
+        <a:font script="Telu" typeface="Gautami"/>
+        <a:font script="Taml" typeface="Latha"/>
+        <a:font script="Syrc" typeface="Estrangelo Edessa"/>
+        <a:font script="Orya" typeface="Kalinga"/>
+        <a:font script="Mlym" typeface="Kartika"/>
+        <a:font script="Laoo" typeface="DokChampa"/>
+        <a:font script="Sinh" typeface="Iskoola Pota"/>
+        <a:font script="Mong" typeface="Mongolian Baiti"/>
+        <a:font script="Viet" typeface="Arial"/>
+        <a:font script="Uigh" typeface="Microsoft Uighur"/>
+        <a:font script="Geor" typeface="Sylfaen"/>
+      </a:minorFont>
+    </a:fontScheme>
+    <a:fmtScheme name="Office">
+      <a:fillStyleLst>
+        <a:solidFill>
+          <a:schemeClr val="phClr"/>
+        </a:solidFill>
+        <a:gradFill rotWithShape="1">
+          <a:gsLst>
+            <a:gs pos="0">
+              <a:schemeClr val="phClr">
+                <a:tint val="50000"/>
+                <a:satMod val="300000"/>
+              </a:schemeClr>
+            </a:gs>
+            <a:gs pos="35000">
+              <a:schemeClr val="phClr">
+                <a:tint val="37000"/>
+                <a:satMod val="300000"/>
+              </a:schemeClr>
+            </a:gs>
+            <a:gs pos="100000">
+              <a:schemeClr val="phClr">
+                <a:tint val="15000"/>
+                <a:satMod val="350000"/>
+              </a:schemeClr>
+            </a:gs>
+          </a:gsLst>
+          <a:lin ang="16200000" scaled="1"/>
+        </a:gradFill>
+        <a:gradFill rotWithShape="1">
+          <a:gsLst>
+            <a:gs pos="0">
+              <a:schemeClr val="phClr">
+                <a:tint val="100000"/>
+                <a:shade val="100000"/>
+                <a:satMod val="130000"/>
+              </a:schemeClr>
+            </a:gs>
+            <a:gs pos="100000">
+              <a:schemeClr val="phClr">
+                <a:tint val="50000"/>
+                <a:shade val="100000"/>
+                <a:satMod val="350000"/>
+              </a:schemeClr>
+            </a:gs>
+          </a:gsLst>
+          <a:lin ang="16200000" scaled="0"/>
+        </a:gradFill>
+      </a:fillStyleLst>
+      <a:lnStyleLst>
+        <a:ln w="9525" cap="flat" cmpd="sng" algn="ctr">
+          <a:solidFill>
+            <a:schemeClr val="phClr">
+              <a:shade val="95000"/>
+              <a:satMod val="105000"/>
+            </a:schemeClr>
+          </a:solidFill>
+          <a:prstDash val="solid"/>
+        </a:ln>
+        <a:ln w="25400" cap="flat" cmpd="sng" algn="ctr">
+          <a:solidFill>
+            <a:schemeClr val="phClr"/>
+          </a:solidFill>
+          <a:prstDash val="solid"/>
+        </a:ln>
+        <a:ln w="38100" cap="flat" cmpd="sng" algn="ctr">
+          <a:solidFill>
+            <a:schemeClr val="phClr"/>
+          </a:solidFill>
+          <a:prstDash val="solid"/>
+        </a:ln>
+      </a:lnStyleLst>
+      <a:effectStyleLst>
+        <a:effectStyle>
+          <a:effectLst>
+            <a:outerShdw blurRad="40000" dist="20000" dir="5400000" rotWithShape="0">
+              <a:srgbClr val="000000">
+                <a:alpha val="38000"/>
+              </a:srgbClr>
+            </a:outerShdw>
+          </a:effectLst>
+        </a:effectStyle>
+        <a:effectStyle>
+          <a:effectLst>
+            <a:outerShdw blurRad="40000" dist="23000" dir="5400000" rotWithShape="0">
+              <a:srgbClr val="000000">
+                <a:alpha val="35000"/>
+              </a:srgbClr>
+            </a:outerShdw>
+          </a:effectLst>
+        </a:effectStyle>
+        <a:effectStyle>
+          <a:effectLst>
+            <a:outerShdw blurRad="40000" dist="23000" dir="5400000" rotWithShape="0">
+              <a:srgbClr val="000000">
+                <a:alpha val="35000"/>
+              </a:srgbClr>
+            </a:outerShdw>
+          </a:effectLst>
+          <a:scene3d>
+            <a:camera prst="orthographicFront">
+              <a:rot lat="0" lon="0" rev="0"/>
+            </a:camera>
+            <a:lightRig rig="threePt" dir="t">
+              <a:rot lat="0" lon="0" rev="1200000"/>
+            </a:lightRig>
+          </a:scene3d>
+          <a:sp3d>
+            <a:bevelT w="63500" h="25400"/>
+          </a:sp3d>
+        </a:effectStyle>
+      </a:effectStyleLst>
+      <a:bgFillStyleLst>
+        <a:solidFill>
+          <a:schemeClr val="phClr"/>
+        </a:solidFill>
+        <a:gradFill rotWithShape="1">
+          <a:gsLst>
+            <a:gs pos="0">
+              <a:schemeClr val="phClr">
+                <a:tint val="40000"/>
+                <a:satMod val="350000"/>
+              </a:schemeClr>
+            </a:gs>
+            <a:gs pos="40000">
+              <a:schemeClr val="phClr">
+                <a:tint val="45000"/>
+                <a:shade val="99000"/>
+                <a:satMod val="350000"/>
+              </a:schemeClr>
+            </a:gs>
+            <a:gs pos="100000">
+              <a:schemeClr val="phClr">
+                <a:shade val="20000"/>
+                <a:satMod val="255000"/>
+              </a:schemeClr>
+            </a:gs>
+          </a:gsLst>
+          <a:path path="circle">
+            <a:fillToRect l="50000" t="-80000" r="50000" b="180000"/>
+          </a:path>
+        </a:gradFill>
+        <a:gradFill rotWithShape="1">
+          <a:gsLst>
+            <a:gs pos="0">
+              <a:schemeClr val="phClr">
+                <a:tint val="80000"/>
+                <a:satMod val="300000"/>
+              </a:schemeClr>
+            </a:gs>
+            <a:gs pos="100000">
+              <a:schemeClr val="phClr">
+                <a:shade val="30000"/>
+                <a:satMod val="200000"/>
+              </a:schemeClr>
+            </a:gs>
+          </a:gsLst>
+          <a:path path="circle">
+            <a:fillToRect l="50000" t="50000" r="50000" b="50000"/>
+          </a:path>
+        </a:gradFill>
+      </a:bgFillStyleLst>
+    </a:fmtScheme>
+  </a:themeElements>
+</a:theme>
+</file>
+
+<file path=ppt/theme/theme2.xml><?xml version="1.0" encoding="utf-8"?>
 <a:theme xmlns:a="http://schemas.openxmlformats.org/drawingml/2006/main" xmlns:r="http://schemas.openxmlformats.org/officeDocument/2006/relationships" name="Office Theme">
   <a:themeElements>
     <a:clrScheme name="Office">
@@ -37445,283 +39164,4 @@
     </a:fmtScheme>
   </a:themeElements>
 </a:theme>
-</file>
-
-<file path=ppt/theme/theme2.xml><?xml version="1.0" encoding="utf-8"?>
-<a:theme xmlns:a="http://schemas.openxmlformats.org/drawingml/2006/main" xmlns:r="http://schemas.openxmlformats.org/officeDocument/2006/relationships" name="Momentum">
-  <a:themeElements>
-    <a:clrScheme name="Momentum">
-      <a:dk1>
-        <a:srgbClr val="C0791B"/>
-      </a:dk1>
-      <a:lt1>
-        <a:srgbClr val="FFFFFF"/>
-      </a:lt1>
-      <a:dk2>
-        <a:srgbClr val="424242"/>
-      </a:dk2>
-      <a:lt2>
-        <a:srgbClr val="8DD8D3"/>
-      </a:lt2>
-      <a:accent1>
-        <a:srgbClr val="0B6374"/>
-      </a:accent1>
-      <a:accent2>
-        <a:srgbClr val="FD5B58"/>
-      </a:accent2>
-      <a:accent3>
-        <a:srgbClr val="599191"/>
-      </a:accent3>
-      <a:accent4>
-        <a:srgbClr val="D7E6A3"/>
-      </a:accent4>
-      <a:accent5>
-        <a:srgbClr val="27278B"/>
-      </a:accent5>
-      <a:accent6>
-        <a:srgbClr val="D558AB"/>
-      </a:accent6>
-      <a:hlink>
-        <a:srgbClr val="27278B"/>
-      </a:hlink>
-      <a:folHlink>
-        <a:srgbClr val="27278B"/>
-      </a:folHlink>
-    </a:clrScheme>
-    <a:fontScheme name="Office">
-      <a:majorFont>
-        <a:latin typeface="Arial"/>
-        <a:ea typeface=""/>
-        <a:cs typeface=""/>
-        <a:font script="Jpan" typeface="ＭＳ Ｐゴシック"/>
-        <a:font script="Hang" typeface="맑은 고딕"/>
-        <a:font script="Hans" typeface="宋体"/>
-        <a:font script="Hant" typeface="新細明體"/>
-        <a:font script="Arab" typeface="Times New Roman"/>
-        <a:font script="Hebr" typeface="Times New Roman"/>
-        <a:font script="Thai" typeface="Angsana New"/>
-        <a:font script="Ethi" typeface="Nyala"/>
-        <a:font script="Beng" typeface="Vrinda"/>
-        <a:font script="Gujr" typeface="Shruti"/>
-        <a:font script="Khmr" typeface="MoolBoran"/>
-        <a:font script="Knda" typeface="Tunga"/>
-        <a:font script="Guru" typeface="Raavi"/>
-        <a:font script="Cans" typeface="Euphemia"/>
-        <a:font script="Cher" typeface="Plantagenet Cherokee"/>
-        <a:font script="Yiii" typeface="Microsoft Yi Baiti"/>
-        <a:font script="Tibt" typeface="Microsoft Himalaya"/>
-        <a:font script="Thaa" typeface="MV Boli"/>
-        <a:font script="Deva" typeface="Mangal"/>
-        <a:font script="Telu" typeface="Gautami"/>
-        <a:font script="Taml" typeface="Latha"/>
-        <a:font script="Syrc" typeface="Estrangelo Edessa"/>
-        <a:font script="Orya" typeface="Kalinga"/>
-        <a:font script="Mlym" typeface="Kartika"/>
-        <a:font script="Laoo" typeface="DokChampa"/>
-        <a:font script="Sinh" typeface="Iskoola Pota"/>
-        <a:font script="Mong" typeface="Mongolian Baiti"/>
-        <a:font script="Viet" typeface="Times New Roman"/>
-        <a:font script="Uigh" typeface="Microsoft Uighur"/>
-        <a:font script="Geor" typeface="Sylfaen"/>
-      </a:majorFont>
-      <a:minorFont>
-        <a:latin typeface="Arial"/>
-        <a:ea typeface=""/>
-        <a:cs typeface=""/>
-        <a:font script="Jpan" typeface="ＭＳ Ｐゴシック"/>
-        <a:font script="Hang" typeface="맑은 고딕"/>
-        <a:font script="Hans" typeface="宋体"/>
-        <a:font script="Hant" typeface="新細明體"/>
-        <a:font script="Arab" typeface="Arial"/>
-        <a:font script="Hebr" typeface="Arial"/>
-        <a:font script="Thai" typeface="Cordia New"/>
-        <a:font script="Ethi" typeface="Nyala"/>
-        <a:font script="Beng" typeface="Vrinda"/>
-        <a:font script="Gujr" typeface="Shruti"/>
-        <a:font script="Khmr" typeface="DaunPenh"/>
-        <a:font script="Knda" typeface="Tunga"/>
-        <a:font script="Guru" typeface="Raavi"/>
-        <a:font script="Cans" typeface="Euphemia"/>
-        <a:font script="Cher" typeface="Plantagenet Cherokee"/>
-        <a:font script="Yiii" typeface="Microsoft Yi Baiti"/>
-        <a:font script="Tibt" typeface="Microsoft Himalaya"/>
-        <a:font script="Thaa" typeface="MV Boli"/>
-        <a:font script="Deva" typeface="Mangal"/>
-        <a:font script="Telu" typeface="Gautami"/>
-        <a:font script="Taml" typeface="Latha"/>
-        <a:font script="Syrc" typeface="Estrangelo Edessa"/>
-        <a:font script="Orya" typeface="Kalinga"/>
-        <a:font script="Mlym" typeface="Kartika"/>
-        <a:font script="Laoo" typeface="DokChampa"/>
-        <a:font script="Sinh" typeface="Iskoola Pota"/>
-        <a:font script="Mong" typeface="Mongolian Baiti"/>
-        <a:font script="Viet" typeface="Arial"/>
-        <a:font script="Uigh" typeface="Microsoft Uighur"/>
-        <a:font script="Geor" typeface="Sylfaen"/>
-      </a:minorFont>
-    </a:fontScheme>
-    <a:fmtScheme name="Office">
-      <a:fillStyleLst>
-        <a:solidFill>
-          <a:schemeClr val="phClr"/>
-        </a:solidFill>
-        <a:gradFill rotWithShape="1">
-          <a:gsLst>
-            <a:gs pos="0">
-              <a:schemeClr val="phClr">
-                <a:tint val="50000"/>
-                <a:satMod val="300000"/>
-              </a:schemeClr>
-            </a:gs>
-            <a:gs pos="35000">
-              <a:schemeClr val="phClr">
-                <a:tint val="37000"/>
-                <a:satMod val="300000"/>
-              </a:schemeClr>
-            </a:gs>
-            <a:gs pos="100000">
-              <a:schemeClr val="phClr">
-                <a:tint val="15000"/>
-                <a:satMod val="350000"/>
-              </a:schemeClr>
-            </a:gs>
-          </a:gsLst>
-          <a:lin ang="16200000" scaled="1"/>
-        </a:gradFill>
-        <a:gradFill rotWithShape="1">
-          <a:gsLst>
-            <a:gs pos="0">
-              <a:schemeClr val="phClr">
-                <a:tint val="100000"/>
-                <a:shade val="100000"/>
-                <a:satMod val="130000"/>
-              </a:schemeClr>
-            </a:gs>
-            <a:gs pos="100000">
-              <a:schemeClr val="phClr">
-                <a:tint val="50000"/>
-                <a:shade val="100000"/>
-                <a:satMod val="350000"/>
-              </a:schemeClr>
-            </a:gs>
-          </a:gsLst>
-          <a:lin ang="16200000" scaled="0"/>
-        </a:gradFill>
-      </a:fillStyleLst>
-      <a:lnStyleLst>
-        <a:ln w="9525" cap="flat" cmpd="sng" algn="ctr">
-          <a:solidFill>
-            <a:schemeClr val="phClr">
-              <a:shade val="95000"/>
-              <a:satMod val="105000"/>
-            </a:schemeClr>
-          </a:solidFill>
-          <a:prstDash val="solid"/>
-        </a:ln>
-        <a:ln w="25400" cap="flat" cmpd="sng" algn="ctr">
-          <a:solidFill>
-            <a:schemeClr val="phClr"/>
-          </a:solidFill>
-          <a:prstDash val="solid"/>
-        </a:ln>
-        <a:ln w="38100" cap="flat" cmpd="sng" algn="ctr">
-          <a:solidFill>
-            <a:schemeClr val="phClr"/>
-          </a:solidFill>
-          <a:prstDash val="solid"/>
-        </a:ln>
-      </a:lnStyleLst>
-      <a:effectStyleLst>
-        <a:effectStyle>
-          <a:effectLst>
-            <a:outerShdw blurRad="40000" dist="20000" dir="5400000" rotWithShape="0">
-              <a:srgbClr val="000000">
-                <a:alpha val="38000"/>
-              </a:srgbClr>
-            </a:outerShdw>
-          </a:effectLst>
-        </a:effectStyle>
-        <a:effectStyle>
-          <a:effectLst>
-            <a:outerShdw blurRad="40000" dist="23000" dir="5400000" rotWithShape="0">
-              <a:srgbClr val="000000">
-                <a:alpha val="35000"/>
-              </a:srgbClr>
-            </a:outerShdw>
-          </a:effectLst>
-        </a:effectStyle>
-        <a:effectStyle>
-          <a:effectLst>
-            <a:outerShdw blurRad="40000" dist="23000" dir="5400000" rotWithShape="0">
-              <a:srgbClr val="000000">
-                <a:alpha val="35000"/>
-              </a:srgbClr>
-            </a:outerShdw>
-          </a:effectLst>
-          <a:scene3d>
-            <a:camera prst="orthographicFront">
-              <a:rot lat="0" lon="0" rev="0"/>
-            </a:camera>
-            <a:lightRig rig="threePt" dir="t">
-              <a:rot lat="0" lon="0" rev="1200000"/>
-            </a:lightRig>
-          </a:scene3d>
-          <a:sp3d>
-            <a:bevelT w="63500" h="25400"/>
-          </a:sp3d>
-        </a:effectStyle>
-      </a:effectStyleLst>
-      <a:bgFillStyleLst>
-        <a:solidFill>
-          <a:schemeClr val="phClr"/>
-        </a:solidFill>
-        <a:gradFill rotWithShape="1">
-          <a:gsLst>
-            <a:gs pos="0">
-              <a:schemeClr val="phClr">
-                <a:tint val="40000"/>
-                <a:satMod val="350000"/>
-              </a:schemeClr>
-            </a:gs>
-            <a:gs pos="40000">
-              <a:schemeClr val="phClr">
-                <a:tint val="45000"/>
-                <a:shade val="99000"/>
-                <a:satMod val="350000"/>
-              </a:schemeClr>
-            </a:gs>
-            <a:gs pos="100000">
-              <a:schemeClr val="phClr">
-                <a:shade val="20000"/>
-                <a:satMod val="255000"/>
-              </a:schemeClr>
-            </a:gs>
-          </a:gsLst>
-          <a:path path="circle">
-            <a:fillToRect l="50000" t="-80000" r="50000" b="180000"/>
-          </a:path>
-        </a:gradFill>
-        <a:gradFill rotWithShape="1">
-          <a:gsLst>
-            <a:gs pos="0">
-              <a:schemeClr val="phClr">
-                <a:tint val="80000"/>
-                <a:satMod val="300000"/>
-              </a:schemeClr>
-            </a:gs>
-            <a:gs pos="100000">
-              <a:schemeClr val="phClr">
-                <a:shade val="30000"/>
-                <a:satMod val="200000"/>
-              </a:schemeClr>
-            </a:gs>
-          </a:gsLst>
-          <a:path path="circle">
-            <a:fillToRect l="50000" t="50000" r="50000" b="50000"/>
-          </a:path>
-        </a:gradFill>
-      </a:bgFillStyleLst>
-    </a:fmtScheme>
-  </a:themeElements>
-</a:theme>
 </file>
</xml_diff>